<commit_message>
feat: Add numerous smoke sample presentations and a Python binding build script, completing the layout helper development plan.
</commit_message>
<xml_diff>
--- a/smoke_samples/14_transitions.pptx
+++ b/smoke_samples/14_transitions.pptx
@@ -10,6 +10,7 @@
     <p:sldId id="259" r:id="rId5"/>
     <p:sldId id="260" r:id="rId6"/>
     <p:sldId id="261" r:id="rId7"/>
+    <p:sldId id="262" r:id="rId8"/>
   </p:sldIdLst>
   <p:sldSz cx="9144000" cy="6858000" type="screen4x3"/>
   <p:notesSz cx="6858000" cy="9144000"/>
@@ -628,6 +629,97 @@
   </p:clrMapOvr>
   <p:transition>
     <p:wheel spokes="3"/>
+  </p:transition>
+</p:sld>
+</file>
+
+<file path=ppt/slides/slide6.xml><?xml version="1.0" encoding="utf-8"?>
+<p:sld xmlns:a="http://schemas.openxmlformats.org/drawingml/2006/main" xmlns:c="http://schemas.openxmlformats.org/drawingml/2006/chart" xmlns:r="http://schemas.openxmlformats.org/officeDocument/2006/relationships" xmlns:p="http://schemas.openxmlformats.org/presentationml/2006/main">
+  <p:cSld>
+    <p:spTree>
+      <p:nvGrpSpPr>
+        <p:cNvPr id="1" name=""/>
+        <p:cNvGrpSpPr/>
+        <p:nvPr/>
+      </p:nvGrpSpPr>
+      <p:grpSpPr>
+        <a:xfrm>
+          <a:off x="0" y="0"/>
+          <a:ext cx="9144000" cy="6858000"/>
+          <a:chOff x="0" y="0"/>
+          <a:chExt cx="9144000" cy="6858000"/>
+        </a:xfrm>
+      </p:grpSpPr>
+      <p:sp>
+        <p:nvSpPr>
+          <p:cNvPr id="2" name="Title"/>
+          <p:cNvSpPr txBox="1"/>
+          <p:nvPr/>
+        </p:nvSpPr>
+        <p:spPr>
+          <a:xfrm>
+            <a:off x="457200" y="274638"/>
+            <a:ext cx="8229600" cy="1143000"/>
+          </a:xfrm>
+          <a:prstGeom prst="rect">
+            <a:avLst/>
+          </a:prstGeom>
+          <a:noFill/>
+        </p:spPr>
+        <p:txBody>
+          <a:bodyPr wrap="square" rtlCol="0" anchor="ctr"/>
+          <a:lstStyle/>
+          <a:p>
+            <a:pPr algn="l"/>
+            <a:r>
+              <a:rPr lang="en-US" sz="4400" b="0" i="0" u="none" dirty="0"/>
+              <a:t>Transition with Sound</a:t>
+            </a:r>
+          </a:p>
+        </p:txBody>
+      </p:sp>
+      <p:sp>
+        <p:nvSpPr>
+          <p:cNvPr id="3" name="Content"/>
+          <p:cNvSpPr txBox="1"/>
+          <p:nvPr/>
+        </p:nvSpPr>
+        <p:spPr>
+          <a:xfrm>
+            <a:off x="457200" y="1600200"/>
+            <a:ext cx="8229600" cy="4572000"/>
+          </a:xfrm>
+          <a:prstGeom prst="rect">
+            <a:avLst/>
+          </a:prstGeom>
+          <a:noFill/>
+        </p:spPr>
+        <p:txBody>
+          <a:bodyPr wrap="square" rtlCol="0" anchor="t"/>
+          <a:lstStyle/>
+          <a:p>
+            <a:pPr lvl="0" marL="457200" indent="-457200">
+              <a:buChar char="•"/>
+            </a:pPr>
+            <a:r>
+              <a:rPr lang="en-US" sz="1800" b="0" i="0" u="none" dirty="0"/>
+              <a:t>This slide has a circle transition with sound</a:t>
+            </a:r>
+          </a:p>
+        </p:txBody>
+      </p:sp>
+    </p:spTree>
+  </p:cSld>
+  <p:clrMapOvr>
+    <a:masterClrMapping/>
+  </p:clrMapOvr>
+  <p:transition>
+    <p:sndAc>
+      <p:stSnd>
+        <p:snd r:embed="rId2" name="transition_sound.wav"/>
+      </p:stSnd>
+    </p:sndAc>
+    <p:circle/>
   </p:transition>
 </p:sld>
 </file>

</xml_diff>